<commit_message>
Refresh pitch deck: evidence-hierarchy results + live-agent win
Slide 10 (RESULTS) reframed to lead with the evidence hierarchy instead of the
in-domain 0.9988: public benchmark CIC-IDS-2017 macro ROC 0.845 → held-out insider
generalization 0.9987 → OT/Modbus 0.895 (G7) → ATT&CK 92.3% + live agent 20-vs-2 on
the insider case → 75% autonomous → MTTD 1.66 d. Slide 7 (attribution) folds in the
measured live-agent win. Design/layout unchanged (text-only edits).
</commit_message>
<xml_diff>
--- a/docs/PRAHARI_Pitch_Deck.pptx
+++ b/docs/PRAHARI_Pitch_Deck.pptx
@@ -3777,7 +3777,7 @@
                 </a:solidFill>
                 <a:latin typeface="Helvetica Neue"/>
               </a:rPr>
-              <a:t>Weeks to hours — measured, not claimed.</a:t>
+              <a:t>Public benchmark, held-out generalization, OT — measured, not claimed.</a:t>
             </a:r>
           </a:p>
         </p:txBody>
@@ -3870,7 +3870,7 @@
                 </a:solidFill>
                 <a:latin typeface="Menlo"/>
               </a:rPr>
-              <a:t>1.66 d</a:t>
+              <a:t>0.845</a:t>
             </a:r>
           </a:p>
           <a:p>
@@ -3892,7 +3892,7 @@
                 </a:solidFill>
                 <a:latin typeface="Helvetica Neue"/>
               </a:rPr>
-              <a:t>MTTD after foothold · vs ~200-day industry mean</a:t>
+              <a:t>CIC-IDS-2017 macro ROC · public benchmark</a:t>
             </a:r>
           </a:p>
         </p:txBody>
@@ -3985,7 +3985,7 @@
                 </a:solidFill>
                 <a:latin typeface="Menlo"/>
               </a:rPr>
-              <a:t>0.9988</a:t>
+              <a:t>0.9987</a:t>
             </a:r>
           </a:p>
           <a:p>
@@ -4007,7 +4007,7 @@
                 </a:solidFill>
                 <a:latin typeface="Helvetica Neue"/>
               </a:rPr>
-              <a:t>UEBA ROC-AUC · 100% recall @ ~1% FPR</a:t>
+              <a:t>held-out insider · 100% recall @1% FPR</a:t>
             </a:r>
           </a:p>
         </p:txBody>
@@ -4100,7 +4100,7 @@
                 </a:solidFill>
                 <a:latin typeface="Menlo"/>
               </a:rPr>
-              <a:t>92.3%</a:t>
+              <a:t>0.895</a:t>
             </a:r>
           </a:p>
           <a:p>
@@ -4122,7 +4122,7 @@
                 </a:solidFill>
                 <a:latin typeface="Helvetica Neue"/>
               </a:rPr>
-              <a:t>ATT&amp;CK technique accuracy · 0 false attributions</a:t>
+              <a:t>OT / Modbus ROC · G7 · IT+OT, one schema</a:t>
             </a:r>
           </a:p>
         </p:txBody>
@@ -4215,7 +4215,7 @@
                 </a:solidFill>
                 <a:latin typeface="Menlo"/>
               </a:rPr>
-              <a:t>75%</a:t>
+              <a:t>92.3%</a:t>
             </a:r>
           </a:p>
           <a:p>
@@ -4237,7 +4237,7 @@
                 </a:solidFill>
                 <a:latin typeface="Helvetica Neue"/>
               </a:rPr>
-              <a:t>of containment steps autonomous</a:t>
+              <a:t>ATT&amp;CK accuracy · live agent 20-vs-2 on insider</a:t>
             </a:r>
           </a:p>
         </p:txBody>
@@ -4330,7 +4330,7 @@
                 </a:solidFill>
                 <a:latin typeface="Menlo"/>
               </a:rPr>
-              <a:t>&lt; 1 s</a:t>
+              <a:t>75%</a:t>
             </a:r>
           </a:p>
           <a:p>
@@ -4352,7 +4352,7 @@
                 </a:solidFill>
                 <a:latin typeface="Helvetica Neue"/>
               </a:rPr>
-              <a:t>MTTR once the incident is confirmed</a:t>
+              <a:t>containment autonomous · platform-gated</a:t>
             </a:r>
           </a:p>
         </p:txBody>
@@ -4445,7 +4445,7 @@
                 </a:solidFill>
                 <a:latin typeface="Menlo"/>
               </a:rPr>
-              <a:t>✓</a:t>
+              <a:t>1.66 d</a:t>
             </a:r>
           </a:p>
           <a:p>
@@ -4467,7 +4467,7 @@
                 </a:solidFill>
                 <a:latin typeface="Helvetica Neue"/>
               </a:rPr>
-              <a:t>audit chain verified · tamper-evident</a:t>
+              <a:t>MTTD after foothold · vs ~200-day mean</a:t>
             </a:r>
           </a:p>
         </p:txBody>
@@ -10855,7 +10855,7 @@
                 </a:solidFill>
                 <a:latin typeface="Helvetica Neue"/>
               </a:rPr>
-              <a:t>Grounded.  </a:t>
+              <a:t>Grounded + live.  </a:t>
             </a:r>
             <a:r>
               <a:rPr sz="1450" b="0">
@@ -10864,7 +10864,7 @@
                 </a:solidFill>
                 <a:latin typeface="Helvetica Neue"/>
               </a:rPr>
-              <a:t>RAG over MITRE ATT&amp;CK + CERT-In advisories.</a:t>
+              <a:t>RAG over ATT&amp;CK + advisories. Live agent beats the mapper 20-vs-2 on the insider case.</a:t>
             </a:r>
           </a:p>
         </p:txBody>

</xml_diff>